<commit_message>
Docs, deck and catalog for the friendlier responses: greeting, BOM, vendor comparison, order story, approval ladder, HTML update email
Co-Authored-By: Claude Sonnet 5.5 <noreply@anthropic.com>
Claude-Session: https://claude.ai/code/session_01Aj5vE1JNcAxiTqppU4PS2Y
</commit_message>
<xml_diff>
--- a/docs/LaunchKit_Provisioner_Management_Deck.pptx
+++ b/docs/LaunchKit_Provisioner_Management_Deck.pptx
@@ -592,7 +592,7 @@
           <a:p>
             <a:r>
               <a:rPr lang="en-US" dirty="0"/>
-              <a:t>Overview slide: the problem, how the agent works, and the three capability pillars. Fictional demo launch: Project Aurora. All data is demo data.</a:t>
+              <a:t>Overview slide: the problem, how the agent works, and the three capability pillars. Fictional demo launch: Spring Launch Event. All data is demo data.</a:t>
             </a:r>
             <a:endParaRPr lang="en-US" dirty="0"/>
           </a:p>
@@ -680,7 +680,7 @@
           <a:p>
             <a:r>
               <a:rPr lang="en-US" dirty="0"/>
-              <a:t>Reference architecture. Every element is a native, editable PowerPoint shape or text box - no images. BigQuery (dataset launchkit) holds all data: reference data (launches, assets, bundle templates, creators, depots and stock, transit lanes, vendors and offers, planning rules, approval policy, approvers), the computed plan (scenarios, scenario lines, decisions, depot holds, vendor disruptions) and the orders and audit log. The root agent calls the three specialist agents as tools, so it writes every reply on every platform including Gemini Enterprise. Application Integration runs four workflows: create_purchase_order, create_depot_transfer, request_approval (a native Approval task that emails the executive Approve / Reject and waits) and send_launch_update.</a:t>
+              <a:t>Reference architecture. Every element is a native, editable PowerPoint shape or text box - no images. BigQuery (dataset launchkit) holds all data: reference data (launches, assets, bundle templates, guests, depots and stock, transit lanes, vendors and offers, planning rules, approval policy, approvers), the computed plan (scenarios, scenario lines, decisions, depot holds, vendor disruptions) and the orders and audit log. The root agent calls the three specialist agents as tools, so it writes every reply on every platform including Gemini Enterprise. Application Integration runs four workflows: create_purchase_order, create_depot_transfer, request_approval (a native Approval task that emails the executive Approve / Reject and waits) and send_launch_update.</a:t>
             </a:r>
             <a:endParaRPr lang="en-US" dirty="0"/>
           </a:p>
@@ -1125,7 +1125,7 @@
                 <a:ea typeface="Calibri" pitchFamily="34" charset="-122"/>
                 <a:cs typeface="Calibri" pitchFamily="34" charset="-120"/>
               </a:rPr>
-              <a:t>A launch-readiness agent on BigQuery and Application Integration: three computed sourcing options, executive sign-off by policy, orders placed automatically</a:t>
+              <a:t>An event procurement agent on BigQuery and Application Integration: one event brief, many vendors, three plain-English options, approval by order size, bulk orders placed automatically</a:t>
             </a:r>
             <a:endParaRPr lang="en-US" sz="2200" dirty="0"/>
           </a:p>
@@ -1278,7 +1278,7 @@
                 <a:ea typeface="Calibri" pitchFamily="34" charset="-122"/>
                 <a:cs typeface="Calibri" pitchFamily="34" charset="-120"/>
               </a:rPr>
-              <a:t>A flagship launch has to equip creators, showrooms and sales teams in several regions before a hard in-hand date and the press embargo. Teams juggle sizes, plugs, vendor lead times and surplus stock in different regional depots, and the only question finance sees is "approve this spend?".</a:t>
+              <a:t>A big event, such as a product launch, needs many different items from many vendors, delivered to guests, venues and sales teams in several regions before a hard deadline. Teams buy item by item, juggle sizes, vendor lead times and surplus stock in different warehouses, and the only question finance sees is "approve this spend?".</a:t>
             </a:r>
             <a:endParaRPr lang="en-US" sz="1500" dirty="0"/>
           </a:p>
@@ -1296,7 +1296,7 @@
                 <a:ea typeface="Calibri" pitchFamily="34" charset="-122"/>
                 <a:cs typeface="Calibri" pitchFamily="34" charset="-120"/>
               </a:rPr>
-              <a:t>The agent plans the launch against the deadline. A central orchestrator breaks the brief into bundles (Brief Analyst), computes three sourcing options from BigQuery data (Sourcing Planner: full new production, smart depot rebalance, certified eco launch), lets the Product Marketing Manager choose, gets a named executive to sign off above the autopilot limit, and has the orders placed (Fulfilment). Purchase orders, depot transfers, the sign-off email and the tracking update run as Google Application Integration workflows. The orchestrator is the only agent that can authorise spend.</a:t>
+              <a:t>Underneath it is still a purchase order, procurement and approval system, but it takes a WHOLE EVENT instead of single items. A central orchestrator turns the brief into a shopping list / Bill of Materials (Brief Analyst), compares many vendors and computes three plain-English options from BigQuery data (Sourcing Planner: buying everything new, use our stock first, buy the rest, certified green option), lets the Product Marketing Manager choose, gets a named executive to sign off above the autopilot limit, and has the orders placed (Fulfilment). Purchase orders, depot transfers, the sign-off email and the tracking update run as Google Application Integration workflows. The orchestrator is the only agent that can authorise spend.</a:t>
             </a:r>
             <a:endParaRPr lang="en-US" sz="1500" dirty="0"/>
           </a:p>
@@ -1578,7 +1578,7 @@
                 <a:ea typeface="Calibri" pitchFamily="34" charset="-122"/>
                 <a:cs typeface="Calibri" pitchFamily="34" charset="-120"/>
               </a:rPr>
-              <a:t>Spare packaging, folios and adapters in regional depots are reused first, nearest depot first, and held while a sign-off is pending. The rebalance option saves cost and often arrives earlier.</a:t>
+              <a:t>Spare packaging, folders and adapters in regional depots are reused first, nearest depot first, and held while a sign-off is pending. The rebalance option saves cost and often arrives earlier.</a:t>
             </a:r>
             <a:endParaRPr lang="en-US" sz="1200" dirty="0"/>
           </a:p>
@@ -2762,7 +2762,7 @@
                 <a:ea typeface="Calibri" pitchFamily="34" charset="-122"/>
                 <a:cs typeface="Calibri" pitchFamily="34" charset="-120"/>
               </a:rPr>
-              <a:t>Brief intake  •  Coordination  •  Decision card for the manager  •  Sign-off gate (autopilot, VP, CMO)  •  Status &amp; results</a:t>
+              <a:t>Hello card  •  Coordination  •  3-choices table  •  Sign-off gate (automatic, VP, CMO)  •  Order story &amp; status</a:t>
             </a:r>
             <a:endParaRPr lang="en-US" sz="850" dirty="0"/>
           </a:p>
@@ -3021,7 +3021,7 @@
                 <a:ea typeface="Calibri" pitchFamily="34" charset="-122"/>
                 <a:cs typeface="Calibri" pitchFamily="34" charset="-120"/>
               </a:rPr>
-              <a:t>Creator, showroom, sales bundles</a:t>
+              <a:t>Shopping list (Bill of Materials)</a:t>
             </a:r>
             <a:endParaRPr lang="en-US" sz="850" dirty="0"/>
           </a:p>
@@ -3039,7 +3039,7 @@
                 <a:ea typeface="Calibri" pitchFamily="34" charset="-122"/>
                 <a:cs typeface="Calibri" pitchFamily="34" charset="-120"/>
               </a:rPr>
-              <a:t>Sizes and plugs from the creator list</a:t>
+              <a:t>Sizes and plugs from the guest list</a:t>
             </a:r>
             <a:endParaRPr lang="en-US" sz="850" dirty="0"/>
           </a:p>
@@ -3225,7 +3225,7 @@
                 <a:ea typeface="Calibri" pitchFamily="34" charset="-122"/>
                 <a:cs typeface="Calibri" pitchFamily="34" charset="-120"/>
               </a:rPr>
-              <a:t>Reuse depot surplus first</a:t>
+              <a:t>Vendor comparison report</a:t>
             </a:r>
             <a:endParaRPr lang="en-US" sz="850" dirty="0"/>
           </a:p>
@@ -3243,7 +3243,7 @@
                 <a:ea typeface="Calibri" pitchFamily="34" charset="-122"/>
                 <a:cs typeface="Calibri" pitchFamily="34" charset="-120"/>
               </a:rPr>
-              <a:t>Lead times vs. the embargo date</a:t>
+              <a:t>Reuse our own stock first</a:t>
             </a:r>
             <a:endParaRPr lang="en-US" sz="850" dirty="0"/>
           </a:p>
@@ -3261,7 +3261,7 @@
                 <a:ea typeface="Calibri" pitchFamily="34" charset="-122"/>
                 <a:cs typeface="Calibri" pitchFamily="34" charset="-120"/>
               </a:rPr>
-              <a:t>Cost, buffer, carbon, risk</a:t>
+              <a:t>Price, spare time, pollution</a:t>
             </a:r>
             <a:endParaRPr lang="en-US" sz="850" dirty="0"/>
           </a:p>
@@ -3447,7 +3447,7 @@
                 <a:ea typeface="Calibri" pitchFamily="34" charset="-122"/>
                 <a:cs typeface="Calibri" pitchFamily="34" charset="-120"/>
               </a:rPr>
-              <a:t>Depot transfer per surplus line</a:t>
+              <a:t>Warehouse move per surplus line</a:t>
             </a:r>
             <a:endParaRPr lang="en-US" sz="850" dirty="0"/>
           </a:p>
@@ -3465,7 +3465,7 @@
                 <a:ea typeface="Calibri" pitchFamily="34" charset="-122"/>
                 <a:cs typeface="Calibri" pitchFamily="34" charset="-120"/>
               </a:rPr>
-              <a:t>Tracking update to the launch team</a:t>
+              <a:t>HTML update + order story</a:t>
             </a:r>
             <a:endParaRPr lang="en-US" sz="850" dirty="0"/>
           </a:p>
@@ -4823,7 +4823,7 @@
                 <a:ea typeface="Calibri" pitchFamily="34" charset="-122"/>
                 <a:cs typeface="Calibri" pitchFamily="34" charset="-120"/>
               </a:rPr>
-              <a:t>launches, assets, bundle_templates, creators, depots, depot_stock, transit_lanes, vendors, vendor_offers, planning_rules, approval_policy, approvers</a:t>
+              <a:t>launches, assets, bundle_templates, guests, depots, depot_stock, transit_lanes, vendors, vendor_offers, planning_rules, approval_policy, approvers</a:t>
             </a:r>
             <a:endParaRPr lang="en-US" sz="650" dirty="0"/>
           </a:p>

</xml_diff>